<commit_message>
Finalize reviewed demo and submission materials for the current map
</commit_message>
<xml_diff>
--- a/output/presentations/astana-walks.pptx
+++ b/output/presentations/astana-walks.pptx
@@ -2,22 +2,22 @@
 <file path=ppt/presentation.xml><?xml version="1.0" encoding="utf-8"?>
 <p:presentation xmlns:p="http://schemas.openxmlformats.org/presentationml/2006/main">
   <p:sldMasterIdLst>
-    <p:sldMasterId xmlns:r="http://schemas.openxmlformats.org/officeDocument/2006/relationships" id="2147483648" r:id="R81721dbcb59f4ed3"/>
+    <p:sldMasterId xmlns:r="http://schemas.openxmlformats.org/officeDocument/2006/relationships" id="2147483648" r:id="R0b1c40b3698c47d0"/>
   </p:sldMasterIdLst>
   <p:notesMasterIdLst>
-    <p:notesMasterId xmlns:r="http://schemas.openxmlformats.org/officeDocument/2006/relationships" r:id="R7b9768ecd9034ee1"/>
+    <p:notesMasterId xmlns:r="http://schemas.openxmlformats.org/officeDocument/2006/relationships" r:id="R60e5c3e4d6d04e99"/>
   </p:notesMasterIdLst>
   <p:sldIdLst>
-    <p:sldId xmlns:r="http://schemas.openxmlformats.org/officeDocument/2006/relationships" id="256" r:id="R4c462ac7ce754e2e"/>
-    <p:sldId xmlns:r="http://schemas.openxmlformats.org/officeDocument/2006/relationships" id="257" r:id="R1cdfd47e214d41e3"/>
-    <p:sldId xmlns:r="http://schemas.openxmlformats.org/officeDocument/2006/relationships" id="258" r:id="R63b1e67466b04161"/>
-    <p:sldId xmlns:r="http://schemas.openxmlformats.org/officeDocument/2006/relationships" id="259" r:id="R1c08ae3cfd824346"/>
-    <p:sldId xmlns:r="http://schemas.openxmlformats.org/officeDocument/2006/relationships" id="260" r:id="R9ad51ebed64e481c"/>
-    <p:sldId xmlns:r="http://schemas.openxmlformats.org/officeDocument/2006/relationships" id="261" r:id="Rc7f2c822f7b44a57"/>
-    <p:sldId xmlns:r="http://schemas.openxmlformats.org/officeDocument/2006/relationships" id="262" r:id="Ra02485f6a0774ae5"/>
-    <p:sldId xmlns:r="http://schemas.openxmlformats.org/officeDocument/2006/relationships" id="263" r:id="Rc433028e13974cae"/>
-    <p:sldId xmlns:r="http://schemas.openxmlformats.org/officeDocument/2006/relationships" id="264" r:id="R57d57c4a5cbf4cdc"/>
-    <p:sldId xmlns:r="http://schemas.openxmlformats.org/officeDocument/2006/relationships" id="265" r:id="R07374f3e5fd7498a"/>
+    <p:sldId xmlns:r="http://schemas.openxmlformats.org/officeDocument/2006/relationships" id="256" r:id="R3ebf23eea9bb4517"/>
+    <p:sldId xmlns:r="http://schemas.openxmlformats.org/officeDocument/2006/relationships" id="257" r:id="R12ee0350da5d4e71"/>
+    <p:sldId xmlns:r="http://schemas.openxmlformats.org/officeDocument/2006/relationships" id="258" r:id="R5a2751a4a81d4f05"/>
+    <p:sldId xmlns:r="http://schemas.openxmlformats.org/officeDocument/2006/relationships" id="259" r:id="R5ca544170f004cae"/>
+    <p:sldId xmlns:r="http://schemas.openxmlformats.org/officeDocument/2006/relationships" id="260" r:id="R3a4f1a47b82143a2"/>
+    <p:sldId xmlns:r="http://schemas.openxmlformats.org/officeDocument/2006/relationships" id="261" r:id="Rf7ae5056b45847bc"/>
+    <p:sldId xmlns:r="http://schemas.openxmlformats.org/officeDocument/2006/relationships" id="262" r:id="R18fcac53be914c77"/>
+    <p:sldId xmlns:r="http://schemas.openxmlformats.org/officeDocument/2006/relationships" id="263" r:id="R99320511d9b44a66"/>
+    <p:sldId xmlns:r="http://schemas.openxmlformats.org/officeDocument/2006/relationships" id="264" r:id="R7650e150908d4496"/>
+    <p:sldId xmlns:r="http://schemas.openxmlformats.org/officeDocument/2006/relationships" id="265" r:id="Rdba542f9768149f7"/>
   </p:sldIdLst>
   <p:sldSz cx="12192000" cy="6858000"/>
   <p:notesSz cx="6858000" cy="9144000"/>
@@ -541,7 +541,7 @@
           <a:lstStyle xmlns:a="http://schemas.openxmlformats.org/drawingml/2006/main"/>
           <a:p xmlns:a="http://schemas.openxmlformats.org/drawingml/2006/main">
             <a:r>
-              <a:t>Для передачи подготовлены исходники, данные с происхождением, сценарии, ограничения и материалы запуска. Прежний снимок сохранён отдельно от расширенной версии. YouTube-публикацию пользователь решил выполнить самостоятельно позже, поэтому ссылка не подменяется вымышленным адресом. Временный сайт зависит от включённого компьютера и туннеля. Проект остаётся прототипом: путь приблизителен, полевой проверки и гарантии безопасности нет. Спасибо, готовы показать фактический сценарий.</a:t>
+              <a:t>Для передачи подготовлены исходники, данные с происхождением, сценарии, ограничения и материалы запуска. Прежний снимок сохранён отдельно от расширенной версии. Принят локальный MP4 длительностью 4:10,64: реальные состояния мобильного интерфейса, с отдельной подписанной вставкой прежней инструкции установки. YouTube-публикацию пользователь решил выполнить самостоятельно позже, поэтому ссылка не подменяется вымышленным адресом. Временный сайт зависит от включённого компьютера и туннеля. Проект остаётся прототипом: путь приблизителен, полевой проверки и гарантии безопасности нет. Спасибо, готовы показать фактический сценарий.</a:t>
             </a:r>
           </a:p>
           <a:p xmlns:a="http://schemas.openxmlformats.org/drawingml/2006/main">
@@ -571,12 +571,27 @@
           </a:p>
           <a:p xmlns:a="http://schemas.openxmlformats.org/drawingml/2006/main">
             <a:r>
+              <a:t>output/video/final/astana-walks-demo.mp4</a:t>
+            </a:r>
+          </a:p>
+          <a:p xmlns:a="http://schemas.openxmlformats.org/drawingml/2006/main">
+            <a:r>
+              <a:t>output/video/final-review.json</a:t>
+            </a:r>
+          </a:p>
+          <a:p xmlns:a="http://schemas.openxmlformats.org/drawingml/2006/main">
+            <a:r>
+              <a:t>One sequential real Chrome tab UI pass, target2fps screenshots. Actual observation timestamps are retained; gaps repeat the last observed frame at real elapsed time. Not a native full-frame screen recording. No desktop or browser chrome captured.</a:t>
+            </a:r>
+          </a:p>
+          <a:p xmlns:a="http://schemas.openxmlformats.org/drawingml/2006/main">
+            <a:r>
               <a:t>Пользователь выбрал самостоятельную загрузку позже; публикация YouTube не подтверждена.</a:t>
             </a:r>
           </a:p>
           <a:p xmlns:a="http://schemas.openxmlformats.org/drawingml/2006/main">
             <a:r>
-              <a:t>Снимок материалов: 2026-10-20T03:12:28+05:00</a:t>
+              <a:t>Снимок материалов: 2026-10-20T03:33:37+05:00</a:t>
             </a:r>
           </a:p>
         </p:txBody>
@@ -1453,7 +1468,7 @@
           <p:cNvPr id="3" name="Title">
             <a:extLst xmlns:a="http://schemas.openxmlformats.org/drawingml/2006/main">
               <a:ext uri="{FF2B5EF4-FFF2-40B4-BE49-F238E27FC236}">
-                <a16:creationId xmlns:a16="http://schemas.microsoft.com/office/drawing/2014/main" id="{107D009A-7CFC-4859-93DA-892050DBB845}"/>
+                <a16:creationId xmlns:a16="http://schemas.microsoft.com/office/drawing/2014/main" id="{0E082BF1-F183-46B6-B1DF-8BCB950FB36D}"/>
               </a:ext>
             </a:extLst>
           </p:cNvPr>
@@ -1682,7 +1697,7 @@
           <p:cNvPr id="2" name="Subtitle">
             <a:extLst xmlns:a="http://schemas.openxmlformats.org/drawingml/2006/main">
               <a:ext uri="{FF2B5EF4-FFF2-40B4-BE49-F238E27FC236}">
-                <a16:creationId xmlns:a16="http://schemas.microsoft.com/office/drawing/2014/main" id="{56581531-6E38-4E0C-93C2-37330BE132BA}"/>
+                <a16:creationId xmlns:a16="http://schemas.microsoft.com/office/drawing/2014/main" id="{19D39664-1C66-47E9-A196-5A9EAA639F17}"/>
               </a:ext>
             </a:extLst>
           </p:cNvPr>
@@ -1928,7 +1943,7 @@
           <p:cNvPr id="2" name="Section title">
             <a:extLst xmlns:a="http://schemas.openxmlformats.org/drawingml/2006/main">
               <a:ext uri="{FF2B5EF4-FFF2-40B4-BE49-F238E27FC236}">
-                <a16:creationId xmlns:a16="http://schemas.microsoft.com/office/drawing/2014/main" id="{17BFA982-1C6E-4ECA-97FC-DBCAF2943091}"/>
+                <a16:creationId xmlns:a16="http://schemas.microsoft.com/office/drawing/2014/main" id="{57252887-EBC9-4BEA-A8D5-CAB92B00D483}"/>
               </a:ext>
             </a:extLst>
           </p:cNvPr>
@@ -2174,7 +2189,7 @@
           <p:cNvPr id="3" name="Title">
             <a:extLst xmlns:a="http://schemas.openxmlformats.org/drawingml/2006/main">
               <a:ext uri="{FF2B5EF4-FFF2-40B4-BE49-F238E27FC236}">
-                <a16:creationId xmlns:a16="http://schemas.microsoft.com/office/drawing/2014/main" id="{93C24B1A-7CCC-436A-9B88-700C7EBDBA80}"/>
+                <a16:creationId xmlns:a16="http://schemas.microsoft.com/office/drawing/2014/main" id="{EF622ED8-665C-4587-94EA-786DBAF67D63}"/>
               </a:ext>
             </a:extLst>
           </p:cNvPr>
@@ -2403,7 +2418,7 @@
           <p:cNvPr id="2" name="Body">
             <a:extLst xmlns:a="http://schemas.openxmlformats.org/drawingml/2006/main">
               <a:ext uri="{FF2B5EF4-FFF2-40B4-BE49-F238E27FC236}">
-                <a16:creationId xmlns:a16="http://schemas.microsoft.com/office/drawing/2014/main" id="{D8057C59-92FD-4CA7-883E-8484CF1ABEDE}"/>
+                <a16:creationId xmlns:a16="http://schemas.microsoft.com/office/drawing/2014/main" id="{E7387EDB-D7FB-4752-8114-E89048F99514}"/>
               </a:ext>
             </a:extLst>
           </p:cNvPr>
@@ -2649,7 +2664,7 @@
           <p:cNvPr id="4" name="Title">
             <a:extLst xmlns:a="http://schemas.openxmlformats.org/drawingml/2006/main">
               <a:ext uri="{FF2B5EF4-FFF2-40B4-BE49-F238E27FC236}">
-                <a16:creationId xmlns:a16="http://schemas.microsoft.com/office/drawing/2014/main" id="{AC16BC51-5137-4A82-A793-229D17DE295D}"/>
+                <a16:creationId xmlns:a16="http://schemas.microsoft.com/office/drawing/2014/main" id="{3D099F4A-EF4E-4CD2-A1C8-CA3A92974FA4}"/>
               </a:ext>
             </a:extLst>
           </p:cNvPr>
@@ -2878,7 +2893,7 @@
           <p:cNvPr id="2" name="Left column">
             <a:extLst xmlns:a="http://schemas.openxmlformats.org/drawingml/2006/main">
               <a:ext uri="{FF2B5EF4-FFF2-40B4-BE49-F238E27FC236}">
-                <a16:creationId xmlns:a16="http://schemas.microsoft.com/office/drawing/2014/main" id="{D4A39316-1FD5-40C9-A86F-D1FB1B827CAD}"/>
+                <a16:creationId xmlns:a16="http://schemas.microsoft.com/office/drawing/2014/main" id="{C32998EF-0BE8-41FC-9B6A-1C874E0AEAF7}"/>
               </a:ext>
             </a:extLst>
           </p:cNvPr>
@@ -3107,7 +3122,7 @@
           <p:cNvPr id="3" name="Right column">
             <a:extLst xmlns:a="http://schemas.openxmlformats.org/drawingml/2006/main">
               <a:ext uri="{FF2B5EF4-FFF2-40B4-BE49-F238E27FC236}">
-                <a16:creationId xmlns:a16="http://schemas.microsoft.com/office/drawing/2014/main" id="{FE307B69-57D3-4F8F-BDD7-ACF80251BD80}"/>
+                <a16:creationId xmlns:a16="http://schemas.microsoft.com/office/drawing/2014/main" id="{1A00A750-4FDA-478F-868F-B05D400F2FE7}"/>
               </a:ext>
             </a:extLst>
           </p:cNvPr>
@@ -3353,7 +3368,7 @@
           <p:cNvPr id="3" name="Title">
             <a:extLst xmlns:a="http://schemas.openxmlformats.org/drawingml/2006/main">
               <a:ext uri="{FF2B5EF4-FFF2-40B4-BE49-F238E27FC236}">
-                <a16:creationId xmlns:a16="http://schemas.microsoft.com/office/drawing/2014/main" id="{DE248D3D-C41A-411E-9BC4-9A6507467ABD}"/>
+                <a16:creationId xmlns:a16="http://schemas.microsoft.com/office/drawing/2014/main" id="{CBE33ACD-1A32-45BF-BEB3-DCE33AEEA395}"/>
               </a:ext>
             </a:extLst>
           </p:cNvPr>
@@ -3582,7 +3597,7 @@
           <p:cNvPr id="2" name="Left column">
             <a:extLst xmlns:a="http://schemas.openxmlformats.org/drawingml/2006/main">
               <a:ext uri="{FF2B5EF4-FFF2-40B4-BE49-F238E27FC236}">
-                <a16:creationId xmlns:a16="http://schemas.microsoft.com/office/drawing/2014/main" id="{6E5CC414-F49C-4F5A-98D9-B4EB72830F76}"/>
+                <a16:creationId xmlns:a16="http://schemas.microsoft.com/office/drawing/2014/main" id="{866B8E42-FEA2-400F-9FFC-E4BA6E172F88}"/>
               </a:ext>
             </a:extLst>
           </p:cNvPr>
@@ -3849,12 +3864,12 @@
   </p:cSld>
   <p:clrMap bg1="lt1" tx1="dk1" bg2="lt2" tx2="dk2" accent1="accent1" accent2="accent2" accent3="accent3" accent4="accent4" accent5="accent5" accent6="accent6" hlink="hlink" folHlink="folHlink"/>
   <p:sldLayoutIdLst>
-    <p:sldLayoutId xmlns:r="http://schemas.openxmlformats.org/officeDocument/2006/relationships" id="2147483649" r:id="R804b95f7dd6a460b"/>
-    <p:sldLayoutId xmlns:r="http://schemas.openxmlformats.org/officeDocument/2006/relationships" id="2147483650" r:id="Ra903abb7c165482f"/>
-    <p:sldLayoutId xmlns:r="http://schemas.openxmlformats.org/officeDocument/2006/relationships" id="2147483651" r:id="R8129a54959ad425c"/>
-    <p:sldLayoutId xmlns:r="http://schemas.openxmlformats.org/officeDocument/2006/relationships" id="2147483652" r:id="R411e7ba65f0048a4"/>
-    <p:sldLayoutId xmlns:r="http://schemas.openxmlformats.org/officeDocument/2006/relationships" id="2147483653" r:id="Re4ddd2190577451a"/>
-    <p:sldLayoutId xmlns:r="http://schemas.openxmlformats.org/officeDocument/2006/relationships" id="2147483654" r:id="Re520e588eac9431a"/>
+    <p:sldLayoutId xmlns:r="http://schemas.openxmlformats.org/officeDocument/2006/relationships" id="2147483649" r:id="Re1caf310d84f48e9"/>
+    <p:sldLayoutId xmlns:r="http://schemas.openxmlformats.org/officeDocument/2006/relationships" id="2147483650" r:id="Rb087abac35fd4336"/>
+    <p:sldLayoutId xmlns:r="http://schemas.openxmlformats.org/officeDocument/2006/relationships" id="2147483651" r:id="R3cd693e90d154eff"/>
+    <p:sldLayoutId xmlns:r="http://schemas.openxmlformats.org/officeDocument/2006/relationships" id="2147483652" r:id="R3ae81cc43f1842dd"/>
+    <p:sldLayoutId xmlns:r="http://schemas.openxmlformats.org/officeDocument/2006/relationships" id="2147483653" r:id="R2635c3ffbc1b43cb"/>
+    <p:sldLayoutId xmlns:r="http://schemas.openxmlformats.org/officeDocument/2006/relationships" id="2147483654" r:id="Re5180cc907a14525"/>
   </p:sldLayoutIdLst>
   <p:txStyles>
     <p:titleStyle>
@@ -4405,7 +4420,7 @@
           <p:cNvPr id="5" name="">
             <a:extLst xmlns:a="http://schemas.openxmlformats.org/drawingml/2006/main">
               <a:ext uri="{FF2B5EF4-FFF2-40B4-BE49-F238E27FC236}">
-                <a16:creationId xmlns:a16="http://schemas.microsoft.com/office/drawing/2014/main" id="{09DE3DE9-FE3D-445A-BFD7-F027EE4AC361}"/>
+                <a16:creationId xmlns:a16="http://schemas.microsoft.com/office/drawing/2014/main" id="{358DE123-2894-49C7-A7AB-0EA36D095023}"/>
               </a:ext>
             </a:extLst>
           </p:cNvPr>
@@ -4561,7 +4576,7 @@
           <p:cNvPr id="2" name="">
             <a:extLst xmlns:a="http://schemas.openxmlformats.org/drawingml/2006/main">
               <a:ext uri="{FF2B5EF4-FFF2-40B4-BE49-F238E27FC236}">
-                <a16:creationId xmlns:a16="http://schemas.microsoft.com/office/drawing/2014/main" id="{98916371-3B05-41DC-BC20-B0FE2BEC7685}"/>
+                <a16:creationId xmlns:a16="http://schemas.microsoft.com/office/drawing/2014/main" id="{FC64914D-03DF-4135-B95F-52FA39A18D1D}"/>
               </a:ext>
             </a:extLst>
           </p:cNvPr>
@@ -4717,7 +4732,7 @@
           <p:cNvPr id="3" name="">
             <a:extLst xmlns:a="http://schemas.openxmlformats.org/drawingml/2006/main">
               <a:ext uri="{FF2B5EF4-FFF2-40B4-BE49-F238E27FC236}">
-                <a16:creationId xmlns:a16="http://schemas.microsoft.com/office/drawing/2014/main" id="{BA86985D-6765-46CE-BCEE-337381F0E826}"/>
+                <a16:creationId xmlns:a16="http://schemas.microsoft.com/office/drawing/2014/main" id="{4E3765A4-84CA-49B7-8DB9-4847EB65D9DF}"/>
               </a:ext>
             </a:extLst>
           </p:cNvPr>
@@ -4896,7 +4911,7 @@
           <p:cNvPr id="4" name="">
             <a:extLst xmlns:a="http://schemas.openxmlformats.org/drawingml/2006/main">
               <a:ext uri="{FF2B5EF4-FFF2-40B4-BE49-F238E27FC236}">
-                <a16:creationId xmlns:a16="http://schemas.microsoft.com/office/drawing/2014/main" id="{EB57C898-C163-4776-902B-04336069A168}"/>
+                <a16:creationId xmlns:a16="http://schemas.microsoft.com/office/drawing/2014/main" id="{FA6B2AB0-9EF2-4C48-974E-F16808961C70}"/>
               </a:ext>
             </a:extLst>
           </p:cNvPr>
@@ -5073,7 +5088,7 @@
     </p:spTree>
     <p:extLst>
       <p:ext uri="{BB962C8B-B14F-4D97-AF65-F5344CB8AC3E}">
-        <p14:creationId xmlns:p14="http://schemas.microsoft.com/office/powerpoint/2010/main" val="1742233500"/>
+        <p14:creationId xmlns:p14="http://schemas.microsoft.com/office/powerpoint/2010/main" val="501821061"/>
       </p:ext>
     </p:extLst>
   </p:cSld>
@@ -5104,7 +5119,7 @@
           <p:cNvPr id="6" name="">
             <a:extLst xmlns:a="http://schemas.openxmlformats.org/drawingml/2006/main">
               <a:ext uri="{FF2B5EF4-FFF2-40B4-BE49-F238E27FC236}">
-                <a16:creationId xmlns:a16="http://schemas.microsoft.com/office/drawing/2014/main" id="{3B89308A-ABFC-49E7-927B-B3CBBD19AC8E}"/>
+                <a16:creationId xmlns:a16="http://schemas.microsoft.com/office/drawing/2014/main" id="{FAEDFDD3-C140-43E2-AC51-5AC7C00E34C3}"/>
               </a:ext>
             </a:extLst>
           </p:cNvPr>
@@ -5260,7 +5275,7 @@
           <p:cNvPr id="2" name="">
             <a:extLst xmlns:a="http://schemas.openxmlformats.org/drawingml/2006/main">
               <a:ext uri="{FF2B5EF4-FFF2-40B4-BE49-F238E27FC236}">
-                <a16:creationId xmlns:a16="http://schemas.microsoft.com/office/drawing/2014/main" id="{9DBBD48A-9323-44F6-B508-D3D05CF507A8}"/>
+                <a16:creationId xmlns:a16="http://schemas.microsoft.com/office/drawing/2014/main" id="{C425A968-01C1-4A6B-8923-7CA155ABA429}"/>
               </a:ext>
             </a:extLst>
           </p:cNvPr>
@@ -5416,7 +5431,7 @@
           <p:cNvPr id="3" name="">
             <a:extLst xmlns:a="http://schemas.openxmlformats.org/drawingml/2006/main">
               <a:ext uri="{FF2B5EF4-FFF2-40B4-BE49-F238E27FC236}">
-                <a16:creationId xmlns:a16="http://schemas.microsoft.com/office/drawing/2014/main" id="{8799A5AD-6F02-4855-B4A4-A62A00EA04E8}"/>
+                <a16:creationId xmlns:a16="http://schemas.microsoft.com/office/drawing/2014/main" id="{4EB24E75-07ED-4287-B497-6D4177EFD4BA}"/>
               </a:ext>
             </a:extLst>
           </p:cNvPr>
@@ -5631,7 +5646,7 @@
                 <a:ea typeface="Arial"/>
                 <a:cs typeface="Arial"/>
               </a:rPr>
-              <a:t>Видео: пользователь загрузит позже</a:t>
+              <a:t>MP4 готов; YouTube пользователь загрузит позже</a:t>
             </a:r>
           </a:p>
         </p:txBody>
@@ -5641,7 +5656,7 @@
           <p:cNvPr id="4" name="">
             <a:extLst xmlns:a="http://schemas.openxmlformats.org/drawingml/2006/main">
               <a:ext uri="{FF2B5EF4-FFF2-40B4-BE49-F238E27FC236}">
-                <a16:creationId xmlns:a16="http://schemas.microsoft.com/office/drawing/2014/main" id="{423079FA-1293-4C55-A14C-5816E4ADF757}"/>
+                <a16:creationId xmlns:a16="http://schemas.microsoft.com/office/drawing/2014/main" id="{1A0F7CC6-E093-4894-B085-B6B24E5685F2}"/>
               </a:ext>
             </a:extLst>
           </p:cNvPr>
@@ -5866,7 +5881,7 @@
           <p:cNvPr id="5" name="">
             <a:extLst xmlns:a="http://schemas.openxmlformats.org/drawingml/2006/main">
               <a:ext uri="{FF2B5EF4-FFF2-40B4-BE49-F238E27FC236}">
-                <a16:creationId xmlns:a16="http://schemas.microsoft.com/office/drawing/2014/main" id="{433703DE-DBA1-4FAB-8C66-19F193C6DF4A}"/>
+                <a16:creationId xmlns:a16="http://schemas.microsoft.com/office/drawing/2014/main" id="{EC4E2138-25E5-4A2A-A438-0FFA19A9C1DB}"/>
               </a:ext>
             </a:extLst>
           </p:cNvPr>
@@ -6020,7 +6035,7 @@
     </p:spTree>
     <p:extLst>
       <p:ext uri="{BB962C8B-B14F-4D97-AF65-F5344CB8AC3E}">
-        <p14:creationId xmlns:p14="http://schemas.microsoft.com/office/powerpoint/2010/main" val="1300593295"/>
+        <p14:creationId xmlns:p14="http://schemas.microsoft.com/office/powerpoint/2010/main" val="769807614"/>
       </p:ext>
     </p:extLst>
   </p:cSld>
@@ -6051,7 +6066,7 @@
           <p:cNvPr id="8" name="">
             <a:extLst xmlns:a="http://schemas.openxmlformats.org/drawingml/2006/main">
               <a:ext uri="{FF2B5EF4-FFF2-40B4-BE49-F238E27FC236}">
-                <a16:creationId xmlns:a16="http://schemas.microsoft.com/office/drawing/2014/main" id="{D8AC4EB2-0800-4961-A708-FE4BEBF4CD62}"/>
+                <a16:creationId xmlns:a16="http://schemas.microsoft.com/office/drawing/2014/main" id="{97BD1214-40C0-4862-A7F5-F11FE00226E6}"/>
               </a:ext>
             </a:extLst>
           </p:cNvPr>
@@ -6207,7 +6222,7 @@
           <p:cNvPr id="2" name="">
             <a:extLst xmlns:a="http://schemas.openxmlformats.org/drawingml/2006/main">
               <a:ext uri="{FF2B5EF4-FFF2-40B4-BE49-F238E27FC236}">
-                <a16:creationId xmlns:a16="http://schemas.microsoft.com/office/drawing/2014/main" id="{ACCBC023-2D7E-4CD5-AC1E-77D3CFA1B7CF}"/>
+                <a16:creationId xmlns:a16="http://schemas.microsoft.com/office/drawing/2014/main" id="{07B018A7-EE7B-4F1F-9EDC-09E7568AFDBB}"/>
               </a:ext>
             </a:extLst>
           </p:cNvPr>
@@ -6363,7 +6378,7 @@
           <p:cNvPr id="3" name="">
             <a:extLst xmlns:a="http://schemas.openxmlformats.org/drawingml/2006/main">
               <a:ext uri="{FF2B5EF4-FFF2-40B4-BE49-F238E27FC236}">
-                <a16:creationId xmlns:a16="http://schemas.microsoft.com/office/drawing/2014/main" id="{CFDCA61D-72CE-407E-B865-20FD472C3D3E}"/>
+                <a16:creationId xmlns:a16="http://schemas.microsoft.com/office/drawing/2014/main" id="{5235CE9E-E7B5-4ABE-B2F9-D2D2844D5FA2}"/>
               </a:ext>
             </a:extLst>
           </p:cNvPr>
@@ -6519,7 +6534,7 @@
           <p:cNvPr id="4" name="">
             <a:extLst xmlns:a="http://schemas.openxmlformats.org/drawingml/2006/main">
               <a:ext uri="{FF2B5EF4-FFF2-40B4-BE49-F238E27FC236}">
-                <a16:creationId xmlns:a16="http://schemas.microsoft.com/office/drawing/2014/main" id="{6CF6E5CF-DF49-49E4-BB4A-63358304BF8A}"/>
+                <a16:creationId xmlns:a16="http://schemas.microsoft.com/office/drawing/2014/main" id="{8D2EC954-67C6-45B5-88CB-52FDC4729AF7}"/>
               </a:ext>
             </a:extLst>
           </p:cNvPr>
@@ -6698,7 +6713,7 @@
           <p:cNvPr id="5" name="">
             <a:extLst xmlns:a="http://schemas.openxmlformats.org/drawingml/2006/main">
               <a:ext uri="{FF2B5EF4-FFF2-40B4-BE49-F238E27FC236}">
-                <a16:creationId xmlns:a16="http://schemas.microsoft.com/office/drawing/2014/main" id="{2F0DCB17-5A85-4E4E-9800-243D00427AB1}"/>
+                <a16:creationId xmlns:a16="http://schemas.microsoft.com/office/drawing/2014/main" id="{93651FED-DDCD-419F-B1A6-65334067459B}"/>
               </a:ext>
             </a:extLst>
           </p:cNvPr>
@@ -6854,7 +6869,7 @@
           <p:cNvPr id="6" name="">
             <a:extLst xmlns:a="http://schemas.openxmlformats.org/drawingml/2006/main">
               <a:ext uri="{FF2B5EF4-FFF2-40B4-BE49-F238E27FC236}">
-                <a16:creationId xmlns:a16="http://schemas.microsoft.com/office/drawing/2014/main" id="{F75B9D5E-4223-464D-9EA4-E8EB96570DEC}"/>
+                <a16:creationId xmlns:a16="http://schemas.microsoft.com/office/drawing/2014/main" id="{2CEF0E74-4437-4A83-B379-D01E57AA2A47}"/>
               </a:ext>
             </a:extLst>
           </p:cNvPr>
@@ -7010,7 +7025,7 @@
           <p:cNvPr id="7" name="">
             <a:extLst xmlns:a="http://schemas.openxmlformats.org/drawingml/2006/main">
               <a:ext uri="{FF2B5EF4-FFF2-40B4-BE49-F238E27FC236}">
-                <a16:creationId xmlns:a16="http://schemas.microsoft.com/office/drawing/2014/main" id="{3A340906-EF2C-4F89-A98A-76AEC12A03E5}"/>
+                <a16:creationId xmlns:a16="http://schemas.microsoft.com/office/drawing/2014/main" id="{593CBC79-E499-4FB8-9EA6-B7430642EDE7}"/>
               </a:ext>
             </a:extLst>
           </p:cNvPr>
@@ -7187,7 +7202,7 @@
     </p:spTree>
     <p:extLst>
       <p:ext uri="{BB962C8B-B14F-4D97-AF65-F5344CB8AC3E}">
-        <p14:creationId xmlns:p14="http://schemas.microsoft.com/office/powerpoint/2010/main" val="752618075"/>
+        <p14:creationId xmlns:p14="http://schemas.microsoft.com/office/powerpoint/2010/main" val="2010043524"/>
       </p:ext>
     </p:extLst>
   </p:cSld>
@@ -7218,7 +7233,7 @@
           <p:cNvPr id="10" name="">
             <a:extLst xmlns:a="http://schemas.openxmlformats.org/drawingml/2006/main">
               <a:ext uri="{FF2B5EF4-FFF2-40B4-BE49-F238E27FC236}">
-                <a16:creationId xmlns:a16="http://schemas.microsoft.com/office/drawing/2014/main" id="{B052F7A8-90E8-4344-A6EB-00FC4B30B1C7}"/>
+                <a16:creationId xmlns:a16="http://schemas.microsoft.com/office/drawing/2014/main" id="{2ADEFD8A-1AC3-419A-B20C-F72969CD3B84}"/>
               </a:ext>
             </a:extLst>
           </p:cNvPr>
@@ -7374,7 +7389,7 @@
           <p:cNvPr id="2" name="">
             <a:extLst xmlns:a="http://schemas.openxmlformats.org/drawingml/2006/main">
               <a:ext uri="{FF2B5EF4-FFF2-40B4-BE49-F238E27FC236}">
-                <a16:creationId xmlns:a16="http://schemas.microsoft.com/office/drawing/2014/main" id="{5C1AB58C-72BA-4FE6-B6A7-31390B8251E5}"/>
+                <a16:creationId xmlns:a16="http://schemas.microsoft.com/office/drawing/2014/main" id="{EB5E17EF-286A-4B8D-92AE-B18CBAB78E87}"/>
               </a:ext>
             </a:extLst>
           </p:cNvPr>
@@ -7530,7 +7545,7 @@
           <p:cNvPr id="3" name="">
             <a:extLst xmlns:a="http://schemas.openxmlformats.org/drawingml/2006/main">
               <a:ext uri="{FF2B5EF4-FFF2-40B4-BE49-F238E27FC236}">
-                <a16:creationId xmlns:a16="http://schemas.microsoft.com/office/drawing/2014/main" id="{B7C58010-9D4B-417E-A47F-9BD12318DFDB}"/>
+                <a16:creationId xmlns:a16="http://schemas.microsoft.com/office/drawing/2014/main" id="{0C9D667D-5E3F-446B-B740-C5A69AB6A07E}"/>
               </a:ext>
             </a:extLst>
           </p:cNvPr>
@@ -7540,7 +7555,7 @@
           <p:nvPr/>
         </p:nvPicPr>
         <p:blipFill>
-          <a:blip xmlns:r="http://schemas.openxmlformats.org/officeDocument/2006/relationships" xmlns:a="http://schemas.openxmlformats.org/drawingml/2006/main" r:embed="R0bbbd413c9374a5d"/>
+          <a:blip xmlns:r="http://schemas.openxmlformats.org/officeDocument/2006/relationships" xmlns:a="http://schemas.openxmlformats.org/drawingml/2006/main" r:embed="R5fb158ffb65049f9"/>
           <a:srcRect xmlns:a="http://schemas.openxmlformats.org/drawingml/2006/main" l="32500" t="49000" r="6500" b="1500"/>
           <a:stretch xmlns:a="http://schemas.openxmlformats.org/drawingml/2006/main"/>
         </p:blipFill>
@@ -7559,7 +7574,7 @@
           <p:cNvPr id="4" name="">
             <a:extLst xmlns:a="http://schemas.openxmlformats.org/drawingml/2006/main">
               <a:ext uri="{FF2B5EF4-FFF2-40B4-BE49-F238E27FC236}">
-                <a16:creationId xmlns:a16="http://schemas.microsoft.com/office/drawing/2014/main" id="{6C479907-7CEB-415E-A53A-A2674C72565B}"/>
+                <a16:creationId xmlns:a16="http://schemas.microsoft.com/office/drawing/2014/main" id="{7C0360F0-8CCA-4DBA-AE53-08BC72F68A41}"/>
               </a:ext>
             </a:extLst>
           </p:cNvPr>
@@ -7569,7 +7584,7 @@
           <p:nvPr/>
         </p:nvPicPr>
         <p:blipFill>
-          <a:blip xmlns:r="http://schemas.openxmlformats.org/officeDocument/2006/relationships" xmlns:a="http://schemas.openxmlformats.org/drawingml/2006/main" r:embed="R84510873cd114380"/>
+          <a:blip xmlns:r="http://schemas.openxmlformats.org/officeDocument/2006/relationships" xmlns:a="http://schemas.openxmlformats.org/drawingml/2006/main" r:embed="R57e9926ca0984468"/>
           <a:stretch xmlns:a="http://schemas.openxmlformats.org/drawingml/2006/main"/>
         </p:blipFill>
         <p:spPr>
@@ -7587,7 +7602,7 @@
           <p:cNvPr id="5" name="">
             <a:extLst xmlns:a="http://schemas.openxmlformats.org/drawingml/2006/main">
               <a:ext uri="{FF2B5EF4-FFF2-40B4-BE49-F238E27FC236}">
-                <a16:creationId xmlns:a16="http://schemas.microsoft.com/office/drawing/2014/main" id="{43418A71-E005-4119-90EC-059923E4A4FC}"/>
+                <a16:creationId xmlns:a16="http://schemas.microsoft.com/office/drawing/2014/main" id="{4648CFC5-810E-41D8-9132-0B1D3FF3601C}"/>
               </a:ext>
             </a:extLst>
           </p:cNvPr>
@@ -7766,7 +7781,7 @@
           <p:cNvPr id="6" name="">
             <a:extLst xmlns:a="http://schemas.openxmlformats.org/drawingml/2006/main">
               <a:ext uri="{FF2B5EF4-FFF2-40B4-BE49-F238E27FC236}">
-                <a16:creationId xmlns:a16="http://schemas.microsoft.com/office/drawing/2014/main" id="{6BD962EB-1CFE-497D-9CB1-8DACF6F6F171}"/>
+                <a16:creationId xmlns:a16="http://schemas.microsoft.com/office/drawing/2014/main" id="{917C6CF8-2641-4C49-B27D-B7A421A67FA9}"/>
               </a:ext>
             </a:extLst>
           </p:cNvPr>
@@ -7922,7 +7937,7 @@
           <p:cNvPr id="7" name="">
             <a:extLst xmlns:a="http://schemas.openxmlformats.org/drawingml/2006/main">
               <a:ext uri="{FF2B5EF4-FFF2-40B4-BE49-F238E27FC236}">
-                <a16:creationId xmlns:a16="http://schemas.microsoft.com/office/drawing/2014/main" id="{39FD079B-4C3A-463D-A48E-FDD8B92F605D}"/>
+                <a16:creationId xmlns:a16="http://schemas.microsoft.com/office/drawing/2014/main" id="{860B2CB9-1317-4E11-86A9-42444B7B7136}"/>
               </a:ext>
             </a:extLst>
           </p:cNvPr>
@@ -8078,7 +8093,7 @@
           <p:cNvPr id="8" name="">
             <a:extLst xmlns:a="http://schemas.openxmlformats.org/drawingml/2006/main">
               <a:ext uri="{FF2B5EF4-FFF2-40B4-BE49-F238E27FC236}">
-                <a16:creationId xmlns:a16="http://schemas.microsoft.com/office/drawing/2014/main" id="{1891D894-3CC3-487D-848D-35682C28CF45}"/>
+                <a16:creationId xmlns:a16="http://schemas.microsoft.com/office/drawing/2014/main" id="{39C669D6-A0C9-4205-AF65-2F71843A4829}"/>
               </a:ext>
             </a:extLst>
           </p:cNvPr>
@@ -8234,7 +8249,7 @@
           <p:cNvPr id="9" name="">
             <a:extLst xmlns:a="http://schemas.openxmlformats.org/drawingml/2006/main">
               <a:ext uri="{FF2B5EF4-FFF2-40B4-BE49-F238E27FC236}">
-                <a16:creationId xmlns:a16="http://schemas.microsoft.com/office/drawing/2014/main" id="{AD08E961-516C-4727-9772-FB2E3DEEDEDC}"/>
+                <a16:creationId xmlns:a16="http://schemas.microsoft.com/office/drawing/2014/main" id="{1058A630-0F55-4E00-9E37-05BD55DC5B24}"/>
               </a:ext>
             </a:extLst>
           </p:cNvPr>
@@ -8388,7 +8403,7 @@
     </p:spTree>
     <p:extLst>
       <p:ext uri="{BB962C8B-B14F-4D97-AF65-F5344CB8AC3E}">
-        <p14:creationId xmlns:p14="http://schemas.microsoft.com/office/powerpoint/2010/main" val="1561823019"/>
+        <p14:creationId xmlns:p14="http://schemas.microsoft.com/office/powerpoint/2010/main" val="1700307742"/>
       </p:ext>
     </p:extLst>
   </p:cSld>
@@ -8419,7 +8434,7 @@
           <p:cNvPr id="5" name="">
             <a:extLst xmlns:a="http://schemas.openxmlformats.org/drawingml/2006/main">
               <a:ext uri="{FF2B5EF4-FFF2-40B4-BE49-F238E27FC236}">
-                <a16:creationId xmlns:a16="http://schemas.microsoft.com/office/drawing/2014/main" id="{67060300-47ED-4157-A09E-C8B1283E13FC}"/>
+                <a16:creationId xmlns:a16="http://schemas.microsoft.com/office/drawing/2014/main" id="{2D343BAA-1E10-4414-82E9-5F42F5BF324E}"/>
               </a:ext>
             </a:extLst>
           </p:cNvPr>
@@ -8575,7 +8590,7 @@
           <p:cNvPr id="2" name="">
             <a:extLst xmlns:a="http://schemas.openxmlformats.org/drawingml/2006/main">
               <a:ext uri="{FF2B5EF4-FFF2-40B4-BE49-F238E27FC236}">
-                <a16:creationId xmlns:a16="http://schemas.microsoft.com/office/drawing/2014/main" id="{917025F6-0CE7-4C4A-9C2D-44C5A733DD6A}"/>
+                <a16:creationId xmlns:a16="http://schemas.microsoft.com/office/drawing/2014/main" id="{ECA99CF6-7FF5-4954-83FA-9DFCF42AEEBE}"/>
               </a:ext>
             </a:extLst>
           </p:cNvPr>
@@ -8731,7 +8746,7 @@
           <p:cNvPr id="3" name="">
             <a:extLst xmlns:a="http://schemas.openxmlformats.org/drawingml/2006/main">
               <a:ext uri="{FF2B5EF4-FFF2-40B4-BE49-F238E27FC236}">
-                <a16:creationId xmlns:a16="http://schemas.microsoft.com/office/drawing/2014/main" id="{0AA0FF51-3D9D-4F58-809C-F60CF35517AB}"/>
+                <a16:creationId xmlns:a16="http://schemas.microsoft.com/office/drawing/2014/main" id="{BEE2FA20-FE86-483B-9D8E-4B34552BC211}"/>
               </a:ext>
             </a:extLst>
           </p:cNvPr>
@@ -8741,7 +8756,7 @@
           <p:nvPr/>
         </p:nvPicPr>
         <p:blipFill>
-          <a:blip xmlns:r="http://schemas.openxmlformats.org/officeDocument/2006/relationships" xmlns:a="http://schemas.openxmlformats.org/drawingml/2006/main" r:embed="Rbf11055cfa94417e"/>
+          <a:blip xmlns:r="http://schemas.openxmlformats.org/officeDocument/2006/relationships" xmlns:a="http://schemas.openxmlformats.org/drawingml/2006/main" r:embed="R0c16dcf02c964620"/>
           <a:srcRect xmlns:a="http://schemas.openxmlformats.org/drawingml/2006/main" l="32500" t="9800" r="6500" b="55200"/>
           <a:stretch xmlns:a="http://schemas.openxmlformats.org/drawingml/2006/main"/>
         </p:blipFill>
@@ -8760,7 +8775,7 @@
           <p:cNvPr id="4" name="">
             <a:extLst xmlns:a="http://schemas.openxmlformats.org/drawingml/2006/main">
               <a:ext uri="{FF2B5EF4-FFF2-40B4-BE49-F238E27FC236}">
-                <a16:creationId xmlns:a16="http://schemas.microsoft.com/office/drawing/2014/main" id="{F5C02387-D252-435C-B062-51AE03FD695D}"/>
+                <a16:creationId xmlns:a16="http://schemas.microsoft.com/office/drawing/2014/main" id="{C6D6D526-7F28-42B8-9646-DA4708DEA1B6}"/>
               </a:ext>
             </a:extLst>
           </p:cNvPr>
@@ -8937,7 +8952,7 @@
     </p:spTree>
     <p:extLst>
       <p:ext uri="{BB962C8B-B14F-4D97-AF65-F5344CB8AC3E}">
-        <p14:creationId xmlns:p14="http://schemas.microsoft.com/office/powerpoint/2010/main" val="1066490268"/>
+        <p14:creationId xmlns:p14="http://schemas.microsoft.com/office/powerpoint/2010/main" val="761561215"/>
       </p:ext>
     </p:extLst>
   </p:cSld>
@@ -8968,7 +8983,7 @@
           <p:cNvPr id="17" name="">
             <a:extLst xmlns:a="http://schemas.openxmlformats.org/drawingml/2006/main">
               <a:ext uri="{FF2B5EF4-FFF2-40B4-BE49-F238E27FC236}">
-                <a16:creationId xmlns:a16="http://schemas.microsoft.com/office/drawing/2014/main" id="{5F1C4DAC-CDDC-47CB-A367-858941C1C314}"/>
+                <a16:creationId xmlns:a16="http://schemas.microsoft.com/office/drawing/2014/main" id="{F4E7D8FD-FC69-4A2B-B0ED-049266280F91}"/>
               </a:ext>
             </a:extLst>
           </p:cNvPr>
@@ -9124,7 +9139,7 @@
           <p:cNvPr id="2" name="">
             <a:extLst xmlns:a="http://schemas.openxmlformats.org/drawingml/2006/main">
               <a:ext uri="{FF2B5EF4-FFF2-40B4-BE49-F238E27FC236}">
-                <a16:creationId xmlns:a16="http://schemas.microsoft.com/office/drawing/2014/main" id="{F3051754-C950-4CF2-A807-B371096D9D77}"/>
+                <a16:creationId xmlns:a16="http://schemas.microsoft.com/office/drawing/2014/main" id="{13F6D45F-3F04-4942-9117-74121D23D0FC}"/>
               </a:ext>
             </a:extLst>
           </p:cNvPr>
@@ -9280,7 +9295,7 @@
           <p:cNvPr id="3" name="">
             <a:extLst xmlns:a="http://schemas.openxmlformats.org/drawingml/2006/main">
               <a:ext uri="{FF2B5EF4-FFF2-40B4-BE49-F238E27FC236}">
-                <a16:creationId xmlns:a16="http://schemas.microsoft.com/office/drawing/2014/main" id="{61F8F1B8-6490-41F9-A7BE-9851875E693D}"/>
+                <a16:creationId xmlns:a16="http://schemas.microsoft.com/office/drawing/2014/main" id="{2AE66628-5F69-4C11-A743-E37DCB2117A8}"/>
               </a:ext>
             </a:extLst>
           </p:cNvPr>
@@ -9436,7 +9451,7 @@
           <p:cNvPr id="4" name="">
             <a:extLst xmlns:a="http://schemas.openxmlformats.org/drawingml/2006/main">
               <a:ext uri="{FF2B5EF4-FFF2-40B4-BE49-F238E27FC236}">
-                <a16:creationId xmlns:a16="http://schemas.microsoft.com/office/drawing/2014/main" id="{25FE82FB-09F8-44EF-8042-C3690BE238CE}"/>
+                <a16:creationId xmlns:a16="http://schemas.microsoft.com/office/drawing/2014/main" id="{D7F72015-9D33-4F04-8C7D-7441AE520620}"/>
               </a:ext>
             </a:extLst>
           </p:cNvPr>
@@ -9592,7 +9607,7 @@
           <p:cNvPr id="5" name="">
             <a:extLst xmlns:a="http://schemas.openxmlformats.org/drawingml/2006/main">
               <a:ext uri="{FF2B5EF4-FFF2-40B4-BE49-F238E27FC236}">
-                <a16:creationId xmlns:a16="http://schemas.microsoft.com/office/drawing/2014/main" id="{40732D37-12FF-4B54-9E41-9BFA57DBAD9A}"/>
+                <a16:creationId xmlns:a16="http://schemas.microsoft.com/office/drawing/2014/main" id="{70541156-3A58-4FE1-8EA1-1F2C8CD27A06}"/>
               </a:ext>
             </a:extLst>
           </p:cNvPr>
@@ -9794,7 +9809,7 @@
           <p:cNvPr id="6" name="">
             <a:extLst xmlns:a="http://schemas.openxmlformats.org/drawingml/2006/main">
               <a:ext uri="{FF2B5EF4-FFF2-40B4-BE49-F238E27FC236}">
-                <a16:creationId xmlns:a16="http://schemas.microsoft.com/office/drawing/2014/main" id="{3FA757B8-A0A6-4456-8499-4A566B34478A}"/>
+                <a16:creationId xmlns:a16="http://schemas.microsoft.com/office/drawing/2014/main" id="{D06BFE9E-1FC5-4206-A560-70EA2D411732}"/>
               </a:ext>
             </a:extLst>
           </p:cNvPr>
@@ -9950,7 +9965,7 @@
           <p:cNvPr id="7" name="">
             <a:extLst xmlns:a="http://schemas.openxmlformats.org/drawingml/2006/main">
               <a:ext uri="{FF2B5EF4-FFF2-40B4-BE49-F238E27FC236}">
-                <a16:creationId xmlns:a16="http://schemas.microsoft.com/office/drawing/2014/main" id="{70ECC5AD-CB58-41F8-848E-7BB7DAE85C22}"/>
+                <a16:creationId xmlns:a16="http://schemas.microsoft.com/office/drawing/2014/main" id="{90A08AE4-74C7-4AFD-8832-283D7BD805EC}"/>
               </a:ext>
             </a:extLst>
           </p:cNvPr>
@@ -10106,7 +10121,7 @@
           <p:cNvPr id="8" name="">
             <a:extLst xmlns:a="http://schemas.openxmlformats.org/drawingml/2006/main">
               <a:ext uri="{FF2B5EF4-FFF2-40B4-BE49-F238E27FC236}">
-                <a16:creationId xmlns:a16="http://schemas.microsoft.com/office/drawing/2014/main" id="{C358AB71-7A5B-4B99-8342-B8DA810143B4}"/>
+                <a16:creationId xmlns:a16="http://schemas.microsoft.com/office/drawing/2014/main" id="{92CF4C89-7E8D-4AD5-8BF8-CAB5681C3EFE}"/>
               </a:ext>
             </a:extLst>
           </p:cNvPr>
@@ -10308,7 +10323,7 @@
           <p:cNvPr id="9" name="">
             <a:extLst xmlns:a="http://schemas.openxmlformats.org/drawingml/2006/main">
               <a:ext uri="{FF2B5EF4-FFF2-40B4-BE49-F238E27FC236}">
-                <a16:creationId xmlns:a16="http://schemas.microsoft.com/office/drawing/2014/main" id="{CD093717-F4E0-41D1-8639-8C112107228D}"/>
+                <a16:creationId xmlns:a16="http://schemas.microsoft.com/office/drawing/2014/main" id="{EEA0E980-64C2-4D20-989B-872CB8A1C19C}"/>
               </a:ext>
             </a:extLst>
           </p:cNvPr>
@@ -10464,7 +10479,7 @@
           <p:cNvPr id="10" name="">
             <a:extLst xmlns:a="http://schemas.openxmlformats.org/drawingml/2006/main">
               <a:ext uri="{FF2B5EF4-FFF2-40B4-BE49-F238E27FC236}">
-                <a16:creationId xmlns:a16="http://schemas.microsoft.com/office/drawing/2014/main" id="{6C221EFA-EE9F-4C01-818E-3CB35FBFD020}"/>
+                <a16:creationId xmlns:a16="http://schemas.microsoft.com/office/drawing/2014/main" id="{FB3BB836-BC6D-4FF7-BAAF-E071F2EE8E19}"/>
               </a:ext>
             </a:extLst>
           </p:cNvPr>
@@ -10620,7 +10635,7 @@
           <p:cNvPr id="11" name="">
             <a:extLst xmlns:a="http://schemas.openxmlformats.org/drawingml/2006/main">
               <a:ext uri="{FF2B5EF4-FFF2-40B4-BE49-F238E27FC236}">
-                <a16:creationId xmlns:a16="http://schemas.microsoft.com/office/drawing/2014/main" id="{ED66D6FA-BA36-4522-8B7B-78454514BEC8}"/>
+                <a16:creationId xmlns:a16="http://schemas.microsoft.com/office/drawing/2014/main" id="{F3F7F63C-7277-4EAB-9E31-BD6B513A1AE8}"/>
               </a:ext>
             </a:extLst>
           </p:cNvPr>
@@ -10822,7 +10837,7 @@
           <p:cNvPr id="12" name="">
             <a:extLst xmlns:a="http://schemas.openxmlformats.org/drawingml/2006/main">
               <a:ext uri="{FF2B5EF4-FFF2-40B4-BE49-F238E27FC236}">
-                <a16:creationId xmlns:a16="http://schemas.microsoft.com/office/drawing/2014/main" id="{678D4D56-1896-4F8A-9A6C-66C47680E71B}"/>
+                <a16:creationId xmlns:a16="http://schemas.microsoft.com/office/drawing/2014/main" id="{9A357609-10DC-4BE8-B418-66F81583DA7B}"/>
               </a:ext>
             </a:extLst>
           </p:cNvPr>
@@ -10978,7 +10993,7 @@
           <p:cNvPr id="13" name="">
             <a:extLst xmlns:a="http://schemas.openxmlformats.org/drawingml/2006/main">
               <a:ext uri="{FF2B5EF4-FFF2-40B4-BE49-F238E27FC236}">
-                <a16:creationId xmlns:a16="http://schemas.microsoft.com/office/drawing/2014/main" id="{91DB8428-CD47-4A15-A7D0-1F21790F4300}"/>
+                <a16:creationId xmlns:a16="http://schemas.microsoft.com/office/drawing/2014/main" id="{FF868694-01D3-40A6-AF01-381291A8F40D}"/>
               </a:ext>
             </a:extLst>
           </p:cNvPr>
@@ -11134,7 +11149,7 @@
           <p:cNvPr id="14" name="">
             <a:extLst xmlns:a="http://schemas.openxmlformats.org/drawingml/2006/main">
               <a:ext uri="{FF2B5EF4-FFF2-40B4-BE49-F238E27FC236}">
-                <a16:creationId xmlns:a16="http://schemas.microsoft.com/office/drawing/2014/main" id="{9B8F67D7-EA71-43A2-A3ED-8A326B7490AC}"/>
+                <a16:creationId xmlns:a16="http://schemas.microsoft.com/office/drawing/2014/main" id="{BA27C47B-1F53-4460-9F7C-4D9D3941FCB8}"/>
               </a:ext>
             </a:extLst>
           </p:cNvPr>
@@ -11336,7 +11351,7 @@
           <p:cNvPr id="15" name="">
             <a:extLst xmlns:a="http://schemas.openxmlformats.org/drawingml/2006/main">
               <a:ext uri="{FF2B5EF4-FFF2-40B4-BE49-F238E27FC236}">
-                <a16:creationId xmlns:a16="http://schemas.microsoft.com/office/drawing/2014/main" id="{15AA109B-F19E-405A-BB85-AC31D70575C0}"/>
+                <a16:creationId xmlns:a16="http://schemas.microsoft.com/office/drawing/2014/main" id="{689AB319-71F9-4A24-9E44-BD4E49830218}"/>
               </a:ext>
             </a:extLst>
           </p:cNvPr>
@@ -11492,7 +11507,7 @@
           <p:cNvPr id="16" name="">
             <a:extLst xmlns:a="http://schemas.openxmlformats.org/drawingml/2006/main">
               <a:ext uri="{FF2B5EF4-FFF2-40B4-BE49-F238E27FC236}">
-                <a16:creationId xmlns:a16="http://schemas.microsoft.com/office/drawing/2014/main" id="{6505937B-4C4B-4481-9856-1565709FF4AC}"/>
+                <a16:creationId xmlns:a16="http://schemas.microsoft.com/office/drawing/2014/main" id="{81292942-32B6-49FA-A5FD-97652E68368F}"/>
               </a:ext>
             </a:extLst>
           </p:cNvPr>
@@ -11646,7 +11661,7 @@
     </p:spTree>
     <p:extLst>
       <p:ext uri="{BB962C8B-B14F-4D97-AF65-F5344CB8AC3E}">
-        <p14:creationId xmlns:p14="http://schemas.microsoft.com/office/powerpoint/2010/main" val="945979573"/>
+        <p14:creationId xmlns:p14="http://schemas.microsoft.com/office/powerpoint/2010/main" val="785782989"/>
       </p:ext>
     </p:extLst>
   </p:cSld>
@@ -11677,7 +11692,7 @@
           <p:cNvPr id="11" name="">
             <a:extLst xmlns:a="http://schemas.openxmlformats.org/drawingml/2006/main">
               <a:ext uri="{FF2B5EF4-FFF2-40B4-BE49-F238E27FC236}">
-                <a16:creationId xmlns:a16="http://schemas.microsoft.com/office/drawing/2014/main" id="{2F78741A-56F8-49D2-B35A-FBAC1145E952}"/>
+                <a16:creationId xmlns:a16="http://schemas.microsoft.com/office/drawing/2014/main" id="{3C99E623-C841-4454-B6CF-A0E9E3B86A16}"/>
               </a:ext>
             </a:extLst>
           </p:cNvPr>
@@ -11833,7 +11848,7 @@
           <p:cNvPr id="2" name="">
             <a:extLst xmlns:a="http://schemas.openxmlformats.org/drawingml/2006/main">
               <a:ext uri="{FF2B5EF4-FFF2-40B4-BE49-F238E27FC236}">
-                <a16:creationId xmlns:a16="http://schemas.microsoft.com/office/drawing/2014/main" id="{B98E1764-1C1E-44D0-B225-E33195DCA2FE}"/>
+                <a16:creationId xmlns:a16="http://schemas.microsoft.com/office/drawing/2014/main" id="{2D8E8E9D-074F-49E6-8D04-8BB52D20D2B8}"/>
               </a:ext>
             </a:extLst>
           </p:cNvPr>
@@ -11989,7 +12004,7 @@
           <p:cNvPr id="3" name="">
             <a:extLst xmlns:a="http://schemas.openxmlformats.org/drawingml/2006/main">
               <a:ext uri="{FF2B5EF4-FFF2-40B4-BE49-F238E27FC236}">
-                <a16:creationId xmlns:a16="http://schemas.microsoft.com/office/drawing/2014/main" id="{C47D6776-9AA6-492A-80CF-6097D554845E}"/>
+                <a16:creationId xmlns:a16="http://schemas.microsoft.com/office/drawing/2014/main" id="{25F56729-0B4B-4EA7-B51C-58257B70EF68}"/>
               </a:ext>
             </a:extLst>
           </p:cNvPr>
@@ -12145,7 +12160,7 @@
           <p:cNvPr id="4" name="">
             <a:extLst xmlns:a="http://schemas.openxmlformats.org/drawingml/2006/main">
               <a:ext uri="{FF2B5EF4-FFF2-40B4-BE49-F238E27FC236}">
-                <a16:creationId xmlns:a16="http://schemas.microsoft.com/office/drawing/2014/main" id="{B7940C94-A49F-4E38-90A5-457ACA48D5E1}"/>
+                <a16:creationId xmlns:a16="http://schemas.microsoft.com/office/drawing/2014/main" id="{55CD0C0F-61B5-4F0F-9A7F-3A70C82D90EE}"/>
               </a:ext>
             </a:extLst>
           </p:cNvPr>
@@ -12301,7 +12316,7 @@
           <p:cNvPr id="5" name="">
             <a:extLst xmlns:a="http://schemas.openxmlformats.org/drawingml/2006/main">
               <a:ext uri="{FF2B5EF4-FFF2-40B4-BE49-F238E27FC236}">
-                <a16:creationId xmlns:a16="http://schemas.microsoft.com/office/drawing/2014/main" id="{76AB3726-8DEE-47D7-9BB5-6CFDC8341B6E}"/>
+                <a16:creationId xmlns:a16="http://schemas.microsoft.com/office/drawing/2014/main" id="{3F497EC3-BE59-4C55-B178-DAC216810C2F}"/>
               </a:ext>
             </a:extLst>
           </p:cNvPr>
@@ -12457,7 +12472,7 @@
           <p:cNvPr id="6" name="">
             <a:extLst xmlns:a="http://schemas.openxmlformats.org/drawingml/2006/main">
               <a:ext uri="{FF2B5EF4-FFF2-40B4-BE49-F238E27FC236}">
-                <a16:creationId xmlns:a16="http://schemas.microsoft.com/office/drawing/2014/main" id="{1A15F388-0597-4D4B-99D3-B283627E1C20}"/>
+                <a16:creationId xmlns:a16="http://schemas.microsoft.com/office/drawing/2014/main" id="{FF7B3EBD-4E4D-4528-978E-6966D5AB3121}"/>
               </a:ext>
             </a:extLst>
           </p:cNvPr>
@@ -12613,7 +12628,7 @@
           <p:cNvPr id="7" name="">
             <a:extLst xmlns:a="http://schemas.openxmlformats.org/drawingml/2006/main">
               <a:ext uri="{FF2B5EF4-FFF2-40B4-BE49-F238E27FC236}">
-                <a16:creationId xmlns:a16="http://schemas.microsoft.com/office/drawing/2014/main" id="{2B53E29B-BCCF-419B-9D12-D0BA6CC967E6}"/>
+                <a16:creationId xmlns:a16="http://schemas.microsoft.com/office/drawing/2014/main" id="{1B04C6BF-F201-43C7-8430-90451327FE23}"/>
               </a:ext>
             </a:extLst>
           </p:cNvPr>
@@ -12792,7 +12807,7 @@
           <p:cNvPr id="8" name="">
             <a:extLst xmlns:a="http://schemas.openxmlformats.org/drawingml/2006/main">
               <a:ext uri="{FF2B5EF4-FFF2-40B4-BE49-F238E27FC236}">
-                <a16:creationId xmlns:a16="http://schemas.microsoft.com/office/drawing/2014/main" id="{BCB3FF9F-D45C-446A-92C6-92955952EE10}"/>
+                <a16:creationId xmlns:a16="http://schemas.microsoft.com/office/drawing/2014/main" id="{C63A9C75-3B71-45B5-BECB-FA9F7E9D52CA}"/>
               </a:ext>
             </a:extLst>
           </p:cNvPr>
@@ -12948,7 +12963,7 @@
           <p:cNvPr id="9" name="">
             <a:extLst xmlns:a="http://schemas.openxmlformats.org/drawingml/2006/main">
               <a:ext uri="{FF2B5EF4-FFF2-40B4-BE49-F238E27FC236}">
-                <a16:creationId xmlns:a16="http://schemas.microsoft.com/office/drawing/2014/main" id="{C8207DB8-25B3-4418-A0E0-567D63C93930}"/>
+                <a16:creationId xmlns:a16="http://schemas.microsoft.com/office/drawing/2014/main" id="{3C2D3CF1-864E-4AEF-9EC2-EDE5B03317D3}"/>
               </a:ext>
             </a:extLst>
           </p:cNvPr>
@@ -13173,7 +13188,7 @@
           <p:cNvPr id="10" name="">
             <a:extLst xmlns:a="http://schemas.openxmlformats.org/drawingml/2006/main">
               <a:ext uri="{FF2B5EF4-FFF2-40B4-BE49-F238E27FC236}">
-                <a16:creationId xmlns:a16="http://schemas.microsoft.com/office/drawing/2014/main" id="{83B7B75D-F5C3-4B5E-B023-8B43F8D7DABA}"/>
+                <a16:creationId xmlns:a16="http://schemas.microsoft.com/office/drawing/2014/main" id="{5C792AD7-3C1B-4276-841B-6E38CC335963}"/>
               </a:ext>
             </a:extLst>
           </p:cNvPr>
@@ -13350,7 +13365,7 @@
     </p:spTree>
     <p:extLst>
       <p:ext uri="{BB962C8B-B14F-4D97-AF65-F5344CB8AC3E}">
-        <p14:creationId xmlns:p14="http://schemas.microsoft.com/office/powerpoint/2010/main" val="452861497"/>
+        <p14:creationId xmlns:p14="http://schemas.microsoft.com/office/powerpoint/2010/main" val="567345988"/>
       </p:ext>
     </p:extLst>
   </p:cSld>
@@ -13381,7 +13396,7 @@
           <p:cNvPr id="7" name="">
             <a:extLst xmlns:a="http://schemas.openxmlformats.org/drawingml/2006/main">
               <a:ext uri="{FF2B5EF4-FFF2-40B4-BE49-F238E27FC236}">
-                <a16:creationId xmlns:a16="http://schemas.microsoft.com/office/drawing/2014/main" id="{783839ED-DEF6-4078-8AAB-302BB689532C}"/>
+                <a16:creationId xmlns:a16="http://schemas.microsoft.com/office/drawing/2014/main" id="{B6EE9A52-9408-4924-9C64-216386C94EAB}"/>
               </a:ext>
             </a:extLst>
           </p:cNvPr>
@@ -13537,7 +13552,7 @@
           <p:cNvPr id="2" name="">
             <a:extLst xmlns:a="http://schemas.openxmlformats.org/drawingml/2006/main">
               <a:ext uri="{FF2B5EF4-FFF2-40B4-BE49-F238E27FC236}">
-                <a16:creationId xmlns:a16="http://schemas.microsoft.com/office/drawing/2014/main" id="{B8FF94B1-81E8-45BB-88AD-6430F8EE2E7D}"/>
+                <a16:creationId xmlns:a16="http://schemas.microsoft.com/office/drawing/2014/main" id="{C50998A8-7F37-4379-9A68-261DA9CAEF6C}"/>
               </a:ext>
             </a:extLst>
           </p:cNvPr>
@@ -13693,7 +13708,7 @@
           <p:cNvPr id="3" name="">
             <a:extLst xmlns:a="http://schemas.openxmlformats.org/drawingml/2006/main">
               <a:ext uri="{FF2B5EF4-FFF2-40B4-BE49-F238E27FC236}">
-                <a16:creationId xmlns:a16="http://schemas.microsoft.com/office/drawing/2014/main" id="{63EFAECF-88C4-4791-84FE-30163277B064}"/>
+                <a16:creationId xmlns:a16="http://schemas.microsoft.com/office/drawing/2014/main" id="{BB617575-13E6-4AAA-B9D9-F3DED3675F20}"/>
               </a:ext>
             </a:extLst>
           </p:cNvPr>
@@ -13849,7 +13864,7 @@
           <p:cNvPr id="4" name="">
             <a:extLst xmlns:a="http://schemas.openxmlformats.org/drawingml/2006/main">
               <a:ext uri="{FF2B5EF4-FFF2-40B4-BE49-F238E27FC236}">
-                <a16:creationId xmlns:a16="http://schemas.microsoft.com/office/drawing/2014/main" id="{1EC61FD6-699E-4050-94FA-46BDA65031C7}"/>
+                <a16:creationId xmlns:a16="http://schemas.microsoft.com/office/drawing/2014/main" id="{DA460CDE-6FBC-4BF7-B3A8-05AE1183D6EC}"/>
               </a:ext>
             </a:extLst>
           </p:cNvPr>
@@ -14005,7 +14020,7 @@
           <p:cNvPr id="5" name="">
             <a:extLst xmlns:a="http://schemas.openxmlformats.org/drawingml/2006/main">
               <a:ext uri="{FF2B5EF4-FFF2-40B4-BE49-F238E27FC236}">
-                <a16:creationId xmlns:a16="http://schemas.microsoft.com/office/drawing/2014/main" id="{D0D74990-0DDA-4412-A558-551B3B0E714C}"/>
+                <a16:creationId xmlns:a16="http://schemas.microsoft.com/office/drawing/2014/main" id="{FD3FD5FF-0672-4E4E-A6C5-02639982F15D}"/>
               </a:ext>
             </a:extLst>
           </p:cNvPr>
@@ -14445,7 +14460,7 @@
           <p:cNvPr id="6" name="">
             <a:extLst xmlns:a="http://schemas.openxmlformats.org/drawingml/2006/main">
               <a:ext uri="{FF2B5EF4-FFF2-40B4-BE49-F238E27FC236}">
-                <a16:creationId xmlns:a16="http://schemas.microsoft.com/office/drawing/2014/main" id="{30D42BFA-12FB-4F44-A7FB-63F8A1232E78}"/>
+                <a16:creationId xmlns:a16="http://schemas.microsoft.com/office/drawing/2014/main" id="{9FB66966-E514-4666-B20D-7AEC4FED008D}"/>
               </a:ext>
             </a:extLst>
           </p:cNvPr>
@@ -14622,7 +14637,7 @@
     </p:spTree>
     <p:extLst>
       <p:ext uri="{BB962C8B-B14F-4D97-AF65-F5344CB8AC3E}">
-        <p14:creationId xmlns:p14="http://schemas.microsoft.com/office/powerpoint/2010/main" val="291755623"/>
+        <p14:creationId xmlns:p14="http://schemas.microsoft.com/office/powerpoint/2010/main" val="702265677"/>
       </p:ext>
     </p:extLst>
   </p:cSld>
@@ -14653,7 +14668,7 @@
           <p:cNvPr id="7" name="">
             <a:extLst xmlns:a="http://schemas.openxmlformats.org/drawingml/2006/main">
               <a:ext uri="{FF2B5EF4-FFF2-40B4-BE49-F238E27FC236}">
-                <a16:creationId xmlns:a16="http://schemas.microsoft.com/office/drawing/2014/main" id="{8754C068-FF30-4213-92D0-3DF2FB872912}"/>
+                <a16:creationId xmlns:a16="http://schemas.microsoft.com/office/drawing/2014/main" id="{3154EBBC-4726-40C8-ACF4-B19ED79B74F5}"/>
               </a:ext>
             </a:extLst>
           </p:cNvPr>
@@ -14809,7 +14824,7 @@
           <p:cNvPr id="2" name="">
             <a:extLst xmlns:a="http://schemas.openxmlformats.org/drawingml/2006/main">
               <a:ext uri="{FF2B5EF4-FFF2-40B4-BE49-F238E27FC236}">
-                <a16:creationId xmlns:a16="http://schemas.microsoft.com/office/drawing/2014/main" id="{7F039D54-673E-4F4A-A2B8-0EC2EA7EEBD1}"/>
+                <a16:creationId xmlns:a16="http://schemas.microsoft.com/office/drawing/2014/main" id="{D3CF2F64-36E5-4EB7-8716-EC59724F7FF7}"/>
               </a:ext>
             </a:extLst>
           </p:cNvPr>
@@ -14965,7 +14980,7 @@
           <p:cNvPr id="3" name="">
             <a:extLst xmlns:a="http://schemas.openxmlformats.org/drawingml/2006/main">
               <a:ext uri="{FF2B5EF4-FFF2-40B4-BE49-F238E27FC236}">
-                <a16:creationId xmlns:a16="http://schemas.microsoft.com/office/drawing/2014/main" id="{DABBD966-04B1-436A-8D55-0036C7469E65}"/>
+                <a16:creationId xmlns:a16="http://schemas.microsoft.com/office/drawing/2014/main" id="{8B39EA5A-1035-4FD9-ADDD-1CB38B52971A}"/>
               </a:ext>
             </a:extLst>
           </p:cNvPr>
@@ -15121,7 +15136,7 @@
           <p:cNvPr id="4" name="">
             <a:extLst xmlns:a="http://schemas.openxmlformats.org/drawingml/2006/main">
               <a:ext uri="{FF2B5EF4-FFF2-40B4-BE49-F238E27FC236}">
-                <a16:creationId xmlns:a16="http://schemas.microsoft.com/office/drawing/2014/main" id="{2B905CE6-085E-409F-BF39-82E2AFC80C75}"/>
+                <a16:creationId xmlns:a16="http://schemas.microsoft.com/office/drawing/2014/main" id="{FC1FF22C-01A1-431B-97B4-1EEAB278702B}"/>
               </a:ext>
             </a:extLst>
           </p:cNvPr>
@@ -15300,7 +15315,7 @@
           <p:cNvPr id="5" name="">
             <a:extLst xmlns:a="http://schemas.openxmlformats.org/drawingml/2006/main">
               <a:ext uri="{FF2B5EF4-FFF2-40B4-BE49-F238E27FC236}">
-                <a16:creationId xmlns:a16="http://schemas.microsoft.com/office/drawing/2014/main" id="{23EC4F20-8ECA-4088-A097-F32666975272}"/>
+                <a16:creationId xmlns:a16="http://schemas.microsoft.com/office/drawing/2014/main" id="{188D0972-560A-48EC-B112-F5A6EA6A25AC}"/>
               </a:ext>
             </a:extLst>
           </p:cNvPr>
@@ -15456,7 +15471,7 @@
           <p:cNvPr id="6" name="">
             <a:extLst xmlns:a="http://schemas.openxmlformats.org/drawingml/2006/main">
               <a:ext uri="{FF2B5EF4-FFF2-40B4-BE49-F238E27FC236}">
-                <a16:creationId xmlns:a16="http://schemas.microsoft.com/office/drawing/2014/main" id="{3A137E92-4E25-42A2-94F1-FDB79C48B5CF}"/>
+                <a16:creationId xmlns:a16="http://schemas.microsoft.com/office/drawing/2014/main" id="{17481754-792D-4313-AC95-3FE6D950D95C}"/>
               </a:ext>
             </a:extLst>
           </p:cNvPr>
@@ -15633,7 +15648,7 @@
     </p:spTree>
     <p:extLst>
       <p:ext uri="{BB962C8B-B14F-4D97-AF65-F5344CB8AC3E}">
-        <p14:creationId xmlns:p14="http://schemas.microsoft.com/office/powerpoint/2010/main" val="1863077832"/>
+        <p14:creationId xmlns:p14="http://schemas.microsoft.com/office/powerpoint/2010/main" val="1621587920"/>
       </p:ext>
     </p:extLst>
   </p:cSld>
@@ -15664,7 +15679,7 @@
           <p:cNvPr id="8" name="">
             <a:extLst xmlns:a="http://schemas.openxmlformats.org/drawingml/2006/main">
               <a:ext uri="{FF2B5EF4-FFF2-40B4-BE49-F238E27FC236}">
-                <a16:creationId xmlns:a16="http://schemas.microsoft.com/office/drawing/2014/main" id="{24A7912D-0D02-4EF1-AB61-5BDB285122A1}"/>
+                <a16:creationId xmlns:a16="http://schemas.microsoft.com/office/drawing/2014/main" id="{296E86DC-F8FA-4F44-B130-F25AB4D91066}"/>
               </a:ext>
             </a:extLst>
           </p:cNvPr>
@@ -15820,7 +15835,7 @@
           <p:cNvPr id="2" name="">
             <a:extLst xmlns:a="http://schemas.openxmlformats.org/drawingml/2006/main">
               <a:ext uri="{FF2B5EF4-FFF2-40B4-BE49-F238E27FC236}">
-                <a16:creationId xmlns:a16="http://schemas.microsoft.com/office/drawing/2014/main" id="{78DA4679-8967-4B24-AA0D-B6D96985079B}"/>
+                <a16:creationId xmlns:a16="http://schemas.microsoft.com/office/drawing/2014/main" id="{D0B21730-13DB-4631-BDF6-764F677A4BEC}"/>
               </a:ext>
             </a:extLst>
           </p:cNvPr>
@@ -15976,7 +15991,7 @@
           <p:cNvPr id="3" name="">
             <a:extLst xmlns:a="http://schemas.openxmlformats.org/drawingml/2006/main">
               <a:ext uri="{FF2B5EF4-FFF2-40B4-BE49-F238E27FC236}">
-                <a16:creationId xmlns:a16="http://schemas.microsoft.com/office/drawing/2014/main" id="{41FBD0B9-6AC9-44D7-A954-8A1EE39EC83A}"/>
+                <a16:creationId xmlns:a16="http://schemas.microsoft.com/office/drawing/2014/main" id="{2DCC6DE2-575B-4F07-B861-0391A85252A7}"/>
               </a:ext>
             </a:extLst>
           </p:cNvPr>
@@ -16155,7 +16170,7 @@
           <p:cNvPr id="4" name="">
             <a:extLst xmlns:a="http://schemas.openxmlformats.org/drawingml/2006/main">
               <a:ext uri="{FF2B5EF4-FFF2-40B4-BE49-F238E27FC236}">
-                <a16:creationId xmlns:a16="http://schemas.microsoft.com/office/drawing/2014/main" id="{E653F4B1-9D19-4607-B402-FC028583A107}"/>
+                <a16:creationId xmlns:a16="http://schemas.microsoft.com/office/drawing/2014/main" id="{ABBDCDA3-3243-446E-935D-1C4A19B5D438}"/>
               </a:ext>
             </a:extLst>
           </p:cNvPr>
@@ -16334,7 +16349,7 @@
           <p:cNvPr id="5" name="">
             <a:extLst xmlns:a="http://schemas.openxmlformats.org/drawingml/2006/main">
               <a:ext uri="{FF2B5EF4-FFF2-40B4-BE49-F238E27FC236}">
-                <a16:creationId xmlns:a16="http://schemas.microsoft.com/office/drawing/2014/main" id="{77213319-15DD-4F97-B0D7-43974E41F3C5}"/>
+                <a16:creationId xmlns:a16="http://schemas.microsoft.com/office/drawing/2014/main" id="{F6A37F92-AAF6-45BA-B1F9-D6171FABEF5F}"/>
               </a:ext>
             </a:extLst>
           </p:cNvPr>
@@ -16490,7 +16505,7 @@
           <p:cNvPr id="6" name="">
             <a:extLst xmlns:a="http://schemas.openxmlformats.org/drawingml/2006/main">
               <a:ext uri="{FF2B5EF4-FFF2-40B4-BE49-F238E27FC236}">
-                <a16:creationId xmlns:a16="http://schemas.microsoft.com/office/drawing/2014/main" id="{007710A1-33A2-432D-B6BD-D557474B8F81}"/>
+                <a16:creationId xmlns:a16="http://schemas.microsoft.com/office/drawing/2014/main" id="{8708BC1D-AE26-45D1-89E4-62AB1B281EF2}"/>
               </a:ext>
             </a:extLst>
           </p:cNvPr>
@@ -16715,7 +16730,7 @@
           <p:cNvPr id="7" name="">
             <a:extLst xmlns:a="http://schemas.openxmlformats.org/drawingml/2006/main">
               <a:ext uri="{FF2B5EF4-FFF2-40B4-BE49-F238E27FC236}">
-                <a16:creationId xmlns:a16="http://schemas.microsoft.com/office/drawing/2014/main" id="{92B6EC28-555B-468B-A16B-C69678E4C346}"/>
+                <a16:creationId xmlns:a16="http://schemas.microsoft.com/office/drawing/2014/main" id="{CCF455E3-DF82-40E1-A352-F68BD780BF4E}"/>
               </a:ext>
             </a:extLst>
           </p:cNvPr>
@@ -16869,7 +16884,7 @@
     </p:spTree>
     <p:extLst>
       <p:ext uri="{BB962C8B-B14F-4D97-AF65-F5344CB8AC3E}">
-        <p14:creationId xmlns:p14="http://schemas.microsoft.com/office/powerpoint/2010/main" val="1701909557"/>
+        <p14:creationId xmlns:p14="http://schemas.microsoft.com/office/powerpoint/2010/main" val="853239542"/>
       </p:ext>
     </p:extLst>
   </p:cSld>

</xml_diff>